<commit_message>
Fix repo consistency and update presentation exports
</commit_message>
<xml_diff>
--- a/docs/presentation/deck_final.pptx
+++ b/docs/presentation/deck_final.pptx
@@ -17,9 +17,6 @@
     <p:sldId id="265" r:id="rId11"/>
     <p:sldId id="266" r:id="rId12"/>
     <p:sldId id="267" r:id="rId13"/>
-    <p:sldId id="268" r:id="rId14"/>
-    <p:sldId id="269" r:id="rId15"/>
-    <p:sldId id="270" r:id="rId16"/>
   </p:sldIdLst>
   <p:sldSz cx="9144000" cy="5143500" type="screen16x9"/>
   <p:notesSz cx="6858000" cy="9144000"/>
@@ -3106,15 +3103,20 @@
       </p:grpSpPr>
       <p:sp>
         <p:nvSpPr>
-          <p:cNvPr id="3" name="Content Placeholder 2"/>
-          <p:cNvSpPr>
-            <a:spLocks noGrp="1"/>
-          </p:cNvSpPr>
-          <p:nvPr>
-            <p:ph idx="1"/>
-          </p:nvPr>
-        </p:nvSpPr>
-        <p:spPr/>
+          <p:cNvPr id="2" name="Title 1"/>
+          <p:cNvSpPr>
+            <a:spLocks noGrp="1"/>
+          </p:cNvSpPr>
+          <p:nvPr>
+            <p:ph type="ctrTitle"/>
+          </p:nvPr>
+        </p:nvSpPr>
+        <p:spPr>
+          <a:xfrm>
+            <a:off x="685800" y="1597819"/>
+            <a:ext cx="7772400" cy="1102519"/>
+          </a:xfrm>
+        </p:spPr>
         <p:txBody>
           <a:bodyPr/>
           <a:lstStyle/>
@@ -3124,7 +3126,39 @@
             </a:pPr>
             <a:r>
               <a:rPr/>
-              <a:t>% Citi Bike Rebalancing With RL and Heuristic Baselines % March 2026</a:t>
+              <a:t>Citi Bike Rebalancing With RL and Heuristic Baselines</a:t>
+            </a:r>
+          </a:p>
+        </p:txBody>
+      </p:sp>
+      <p:sp>
+        <p:nvSpPr>
+          <p:cNvPr id="3" name="Subtitle 2"/>
+          <p:cNvSpPr>
+            <a:spLocks noGrp="1"/>
+          </p:cNvSpPr>
+          <p:nvPr>
+            <p:ph idx="1" type="subTitle"/>
+          </p:nvPr>
+        </p:nvSpPr>
+        <p:spPr>
+          <a:xfrm>
+            <a:off x="1371600" y="2914650"/>
+            <a:ext cx="6400800" cy="1314450"/>
+          </a:xfrm>
+        </p:spPr>
+        <p:txBody>
+          <a:bodyPr/>
+          <a:lstStyle/>
+          <a:p>
+            <a:pPr lvl="0" indent="0" marL="0">
+              <a:buNone/>
+            </a:pPr>
+            <a:br/>
+            <a:br/>
+            <a:r>
+              <a:rPr/>
+              <a:t>March 2026</a:t>
             </a:r>
           </a:p>
         </p:txBody>
@@ -3135,235 +3169,6 @@
 </file>
 
 <file path=ppt/slides/slide10.xml><?xml version="1.0" encoding="utf-8"?>
-<p:sld xmlns:a="http://schemas.openxmlformats.org/drawingml/2006/main" xmlns:r="http://schemas.openxmlformats.org/officeDocument/2006/relationships" xmlns:p="http://schemas.openxmlformats.org/presentationml/2006/main">
-  <p:cSld>
-    <p:spTree>
-      <p:nvGrpSpPr>
-        <p:cNvPr id="1" name=""/>
-        <p:cNvGrpSpPr/>
-        <p:nvPr/>
-      </p:nvGrpSpPr>
-      <p:grpSpPr>
-        <a:xfrm>
-          <a:off x="0" y="0"/>
-          <a:ext cx="0" cy="0"/>
-          <a:chOff x="0" y="0"/>
-          <a:chExt cx="0" cy="0"/>
-        </a:xfrm>
-      </p:grpSpPr>
-      <p:sp>
-        <p:nvSpPr>
-          <p:cNvPr id="3" name="Content Placeholder 2"/>
-          <p:cNvSpPr>
-            <a:spLocks noGrp="1"/>
-          </p:cNvSpPr>
-          <p:nvPr>
-            <p:ph idx="1"/>
-          </p:nvPr>
-        </p:nvSpPr>
-        <p:spPr/>
-        <p:txBody>
-          <a:bodyPr/>
-          <a:lstStyle/>
-          <a:p>
-            <a:pPr lvl="0" indent="0" marL="0">
-              <a:buNone/>
-            </a:pPr>
-            <a:r>
-              <a:rPr/>
-              <a:t>{ width=90% }</a:t>
-            </a:r>
-          </a:p>
-        </p:txBody>
-      </p:sp>
-    </p:spTree>
-  </p:cSld>
-</p:sld>
-</file>
-
-<file path=ppt/slides/slide11.xml><?xml version="1.0" encoding="utf-8"?>
-<p:sld xmlns:a="http://schemas.openxmlformats.org/drawingml/2006/main" xmlns:r="http://schemas.openxmlformats.org/officeDocument/2006/relationships" xmlns:p="http://schemas.openxmlformats.org/presentationml/2006/main">
-  <p:cSld>
-    <p:spTree>
-      <p:nvGrpSpPr>
-        <p:cNvPr id="1" name=""/>
-        <p:cNvGrpSpPr/>
-        <p:nvPr/>
-      </p:nvGrpSpPr>
-      <p:grpSpPr>
-        <a:xfrm>
-          <a:off x="0" y="0"/>
-          <a:ext cx="0" cy="0"/>
-          <a:chOff x="0" y="0"/>
-          <a:chExt cx="0" cy="0"/>
-        </a:xfrm>
-      </p:grpSpPr>
-      <p:sp>
-        <p:nvSpPr>
-          <p:cNvPr id="2" name="Title 1"/>
-          <p:cNvSpPr>
-            <a:spLocks noGrp="1"/>
-          </p:cNvSpPr>
-          <p:nvPr>
-            <p:ph type="title"/>
-          </p:nvPr>
-        </p:nvSpPr>
-        <p:spPr>
-          <a:xfrm>
-            <a:off x="457201" y="204787"/>
-            <a:ext cx="3008313" cy="871538"/>
-          </a:xfrm>
-        </p:spPr>
-        <p:txBody>
-          <a:bodyPr/>
-          <a:lstStyle/>
-          <a:p>
-            <a:pPr lvl="0" indent="0" marL="0">
-              <a:buNone/>
-            </a:pPr>
-            <a:r>
-              <a:rPr/>
-              <a:t>DQN Result and Caveat</a:t>
-            </a:r>
-          </a:p>
-        </p:txBody>
-      </p:sp>
-      <p:sp>
-        <p:nvSpPr>
-          <p:cNvPr id="4" name="Text Placeholder 3"/>
-          <p:cNvSpPr>
-            <a:spLocks noGrp="1"/>
-          </p:cNvSpPr>
-          <p:nvPr>
-            <p:ph idx="2" sz="half" type="body"/>
-          </p:nvPr>
-        </p:nvSpPr>
-        <p:spPr/>
-        <p:txBody>
-          <a:bodyPr/>
-          <a:lstStyle/>
-          <a:p>
-            <a:pPr lvl="0"/>
-            <a:r>
-              <a:rPr/>
-              <a:t>Unregularized DQN over-moved bikes and underperformed the heuristic.</a:t>
-            </a:r>
-          </a:p>
-          <a:p>
-            <a:pPr lvl="0"/>
-            <a:r>
-              <a:rPr/>
-              <a:t>Move-margin regularization improved the best DQN run: </a:t>
-            </a:r>
-            <a:r>
-              <a:rPr>
-                <a:latin typeface="Courier"/>
-              </a:rPr>
-              <a:t>123.63</a:t>
-            </a:r>
-            <a:r>
-              <a:rPr/>
-              <a:t> vs heuristic </a:t>
-            </a:r>
-            <a:r>
-              <a:rPr>
-                <a:latin typeface="Courier"/>
-              </a:rPr>
-              <a:t>122.45</a:t>
-            </a:r>
-          </a:p>
-          <a:p>
-            <a:pPr lvl="0"/>
-            <a:r>
-              <a:rPr/>
-              <a:t>But that win was not stable across seeds.</a:t>
-            </a:r>
-          </a:p>
-        </p:txBody>
-      </p:sp>
-      <p:pic>
-        <p:nvPicPr>
-          <p:cNvPr descr="outputs/figures/jc_2025_full_year_to_202602_holdout_dqn_margin_v1_policy_comparison.png" id="0" name="Picture 1"/>
-          <p:cNvPicPr>
-            <a:picLocks noGrp="1" noChangeAspect="1"/>
-          </p:cNvPicPr>
-          <p:nvPr/>
-        </p:nvPicPr>
-        <p:blipFill>
-          <a:blip r:embed="rId2"/>
-          <a:stretch>
-            <a:fillRect/>
-          </a:stretch>
-        </p:blipFill>
-        <p:spPr bwMode="auto">
-          <a:xfrm>
-            <a:off x="3568700" y="1346200"/>
-            <a:ext cx="5105400" cy="2082800"/>
-          </a:xfrm>
-          <a:prstGeom prst="rect">
-            <a:avLst/>
-          </a:prstGeom>
-          <a:noFill/>
-          <a:ln w="9525">
-            <a:noFill/>
-            <a:headEnd/>
-            <a:tailEnd/>
-          </a:ln>
-        </p:spPr>
-      </p:pic>
-    </p:spTree>
-  </p:cSld>
-</p:sld>
-</file>
-
-<file path=ppt/slides/slide12.xml><?xml version="1.0" encoding="utf-8"?>
-<p:sld xmlns:a="http://schemas.openxmlformats.org/drawingml/2006/main" xmlns:r="http://schemas.openxmlformats.org/officeDocument/2006/relationships" xmlns:p="http://schemas.openxmlformats.org/presentationml/2006/main">
-  <p:cSld>
-    <p:spTree>
-      <p:nvGrpSpPr>
-        <p:cNvPr id="1" name=""/>
-        <p:cNvGrpSpPr/>
-        <p:nvPr/>
-      </p:nvGrpSpPr>
-      <p:grpSpPr>
-        <a:xfrm>
-          <a:off x="0" y="0"/>
-          <a:ext cx="0" cy="0"/>
-          <a:chOff x="0" y="0"/>
-          <a:chExt cx="0" cy="0"/>
-        </a:xfrm>
-      </p:grpSpPr>
-      <p:sp>
-        <p:nvSpPr>
-          <p:cNvPr id="3" name="Content Placeholder 2"/>
-          <p:cNvSpPr>
-            <a:spLocks noGrp="1"/>
-          </p:cNvSpPr>
-          <p:nvPr>
-            <p:ph idx="1"/>
-          </p:nvPr>
-        </p:nvSpPr>
-        <p:spPr/>
-        <p:txBody>
-          <a:bodyPr/>
-          <a:lstStyle/>
-          <a:p>
-            <a:pPr lvl="0" indent="0" marL="0">
-              <a:buNone/>
-            </a:pPr>
-            <a:r>
-              <a:rPr/>
-              <a:t>{ width=90% }</a:t>
-            </a:r>
-          </a:p>
-        </p:txBody>
-      </p:sp>
-    </p:spTree>
-  </p:cSld>
-</p:sld>
-</file>
-
-<file path=ppt/slides/slide13.xml><?xml version="1.0" encoding="utf-8"?>
 <p:sld xmlns:a="http://schemas.openxmlformats.org/drawingml/2006/main" xmlns:r="http://schemas.openxmlformats.org/officeDocument/2006/relationships" xmlns:p="http://schemas.openxmlformats.org/presentationml/2006/main">
   <p:cSld>
     <p:spTree>
@@ -3630,7 +3435,7 @@
 </p:sld>
 </file>
 
-<file path=ppt/slides/slide14.xml><?xml version="1.0" encoding="utf-8"?>
+<file path=ppt/slides/slide11.xml><?xml version="1.0" encoding="utf-8"?>
 <p:sld xmlns:a="http://schemas.openxmlformats.org/drawingml/2006/main" xmlns:r="http://schemas.openxmlformats.org/officeDocument/2006/relationships" xmlns:p="http://schemas.openxmlformats.org/presentationml/2006/main">
   <p:cSld>
     <p:spTree>
@@ -3675,7 +3480,7 @@
 </p:sld>
 </file>
 
-<file path=ppt/slides/slide15.xml><?xml version="1.0" encoding="utf-8"?>
+<file path=ppt/slides/slide12.xml><?xml version="1.0" encoding="utf-8"?>
 <p:sld xmlns:a="http://schemas.openxmlformats.org/drawingml/2006/main" xmlns:r="http://schemas.openxmlformats.org/officeDocument/2006/relationships" xmlns:p="http://schemas.openxmlformats.org/presentationml/2006/main">
   <p:cSld>
     <p:spTree>
@@ -4386,7 +4191,7 @@
       </p:sp>
       <p:pic>
         <p:nvPicPr>
-          <p:cNvPr descr="outputs/figures/jc_202602_top5_calendar_heuristic_v1_policy_comparison.png" id="0" name="Picture 1"/>
+          <p:cNvPr descr="assets/jc_202602_top5_calendar_heuristic_v1_policy_comparison.png" id="0" name="Picture 1"/>
           <p:cNvPicPr>
             <a:picLocks noGrp="1" noChangeAspect="1"/>
           </p:cNvPicPr>
@@ -4438,15 +4243,20 @@
       </p:grpSpPr>
       <p:sp>
         <p:nvSpPr>
-          <p:cNvPr id="3" name="Content Placeholder 2"/>
-          <p:cNvSpPr>
-            <a:spLocks noGrp="1"/>
-          </p:cNvSpPr>
-          <p:nvPr>
-            <p:ph idx="1"/>
-          </p:nvPr>
-        </p:nvSpPr>
-        <p:spPr/>
+          <p:cNvPr id="2" name="Title 1"/>
+          <p:cNvSpPr>
+            <a:spLocks noGrp="1"/>
+          </p:cNvSpPr>
+          <p:nvPr>
+            <p:ph type="title"/>
+          </p:nvPr>
+        </p:nvSpPr>
+        <p:spPr>
+          <a:xfrm>
+            <a:off x="457201" y="204787"/>
+            <a:ext cx="3008313" cy="871538"/>
+          </a:xfrm>
+        </p:spPr>
         <p:txBody>
           <a:bodyPr/>
           <a:lstStyle/>
@@ -4456,11 +4266,103 @@
             </a:pPr>
             <a:r>
               <a:rPr/>
-              <a:t>{ width=90% }</a:t>
-            </a:r>
-          </a:p>
-        </p:txBody>
-      </p:sp>
+              <a:t>Main Seasonal Holdout Result</a:t>
+            </a:r>
+          </a:p>
+        </p:txBody>
+      </p:sp>
+      <p:sp>
+        <p:nvSpPr>
+          <p:cNvPr id="4" name="Text Placeholder 3"/>
+          <p:cNvSpPr>
+            <a:spLocks noGrp="1"/>
+          </p:cNvSpPr>
+          <p:nvPr>
+            <p:ph idx="2" sz="half" type="body"/>
+          </p:nvPr>
+        </p:nvSpPr>
+        <p:spPr/>
+        <p:txBody>
+          <a:bodyPr/>
+          <a:lstStyle/>
+          <a:p>
+            <a:pPr lvl="0"/>
+            <a:r>
+              <a:rPr/>
+              <a:t>Strict holdout: train through January 2026, test on February 2026</a:t>
+            </a:r>
+          </a:p>
+          <a:p>
+            <a:pPr lvl="0"/>
+            <a:r>
+              <a:rPr/>
+              <a:t>No-op baseline: </a:t>
+            </a:r>
+            <a:r>
+              <a:rPr>
+                <a:latin typeface="Courier"/>
+              </a:rPr>
+              <a:t>109.33</a:t>
+            </a:r>
+          </a:p>
+          <a:p>
+            <a:pPr lvl="0"/>
+            <a:r>
+              <a:rPr/>
+              <a:t>Heuristic baseline: </a:t>
+            </a:r>
+            <a:r>
+              <a:rPr>
+                <a:latin typeface="Courier"/>
+              </a:rPr>
+              <a:t>122.45</a:t>
+            </a:r>
+          </a:p>
+          <a:p>
+            <a:pPr lvl="0"/>
+            <a:r>
+              <a:rPr/>
+              <a:t>Weather-aware tabular Q: </a:t>
+            </a:r>
+            <a:r>
+              <a:rPr>
+                <a:latin typeface="Courier"/>
+              </a:rPr>
+              <a:t>122.21</a:t>
+            </a:r>
+          </a:p>
+        </p:txBody>
+      </p:sp>
+      <p:pic>
+        <p:nvPicPr>
+          <p:cNvPr descr="assets/jc_2025_full_year_to_202602_holdout_weather_v1_policy_comparison.png" id="0" name="Picture 1"/>
+          <p:cNvPicPr>
+            <a:picLocks noGrp="1" noChangeAspect="1"/>
+          </p:cNvPicPr>
+          <p:nvPr/>
+        </p:nvPicPr>
+        <p:blipFill>
+          <a:blip r:embed="rId2"/>
+          <a:stretch>
+            <a:fillRect/>
+          </a:stretch>
+        </p:blipFill>
+        <p:spPr bwMode="auto">
+          <a:xfrm>
+            <a:off x="3568700" y="1346200"/>
+            <a:ext cx="5105400" cy="2082800"/>
+          </a:xfrm>
+          <a:prstGeom prst="rect">
+            <a:avLst/>
+          </a:prstGeom>
+          <a:noFill/>
+          <a:ln w="9525">
+            <a:noFill/>
+            <a:headEnd/>
+            <a:tailEnd/>
+          </a:ln>
+        </p:spPr>
+      </p:pic>
     </p:spTree>
   </p:cSld>
 </p:sld>
@@ -4508,7 +4410,7 @@
             </a:pPr>
             <a:r>
               <a:rPr/>
-              <a:t>Main Seasonal Holdout Result</a:t>
+              <a:t>DQN Result and Caveat</a:t>
             </a:r>
           </a:p>
         </p:txBody>
@@ -4531,27 +4433,24 @@
             <a:pPr lvl="0"/>
             <a:r>
               <a:rPr/>
-              <a:t>Strict holdout: train through January 2026, test on February 2026</a:t>
+              <a:t>Unregularized DQN over-moved bikes and underperformed the heuristic.</a:t>
             </a:r>
           </a:p>
           <a:p>
             <a:pPr lvl="0"/>
             <a:r>
               <a:rPr/>
-              <a:t>No-op baseline: </a:t>
+              <a:t>Move-margin regularization improved the best DQN run: </a:t>
             </a:r>
             <a:r>
               <a:rPr>
                 <a:latin typeface="Courier"/>
               </a:rPr>
-              <a:t>109.33</a:t>
-            </a:r>
-          </a:p>
-          <a:p>
-            <a:pPr lvl="0"/>
-            <a:r>
-              <a:rPr/>
-              <a:t>Heuristic baseline: </a:t>
+              <a:t>123.63</a:t>
+            </a:r>
+            <a:r>
+              <a:rPr/>
+              <a:t> vs heuristic </a:t>
             </a:r>
             <a:r>
               <a:rPr>
@@ -4564,20 +4463,14 @@
             <a:pPr lvl="0"/>
             <a:r>
               <a:rPr/>
-              <a:t>Weather-aware tabular Q: </a:t>
-            </a:r>
-            <a:r>
-              <a:rPr>
-                <a:latin typeface="Courier"/>
-              </a:rPr>
-              <a:t>122.21</a:t>
+              <a:t>But that win was not stable across seeds.</a:t>
             </a:r>
           </a:p>
         </p:txBody>
       </p:sp>
       <p:pic>
         <p:nvPicPr>
-          <p:cNvPr descr="outputs/figures/jc_2025_full_year_to_202602_holdout_weather_v1_policy_comparison.png" id="0" name="Picture 1"/>
+          <p:cNvPr descr="assets/jc_2025_full_year_to_202602_holdout_dqn_margin_v1_policy_comparison.png" id="0" name="Picture 1"/>
           <p:cNvPicPr>
             <a:picLocks noGrp="1" noChangeAspect="1"/>
           </p:cNvPicPr>

</xml_diff>